<commit_message>
Remove all Instruqt references - labs recorded on bare metal
</commit_message>
<xml_diff>
--- a/docs/suse-virt-storylane-deck.pptx
+++ b/docs/suse-virt-storylane-deck.pptx
@@ -5923,7 +5923,7 @@
                   <a:srgbClr val="E6EDF3"/>
                 </a:solidFill>
               </a:rPr>
-              <a:t>Try the rodeo</a:t>
+              <a:t>Try it yourself</a:t>
             </a:r>
           </a:p>
         </p:txBody>
@@ -5957,7 +5957,7 @@
                   <a:srgbClr val="8B949E"/>
                 </a:solidFill>
               </a:rPr>
-              <a:t>Run the Instruqt hands-on lab. No install needed. A 3-node SUSE Virtualization cluster ready in minutes.</a:t>
+              <a:t>Follow the 0-to-Hero lab guide against a real bare-metal SUSE Virtualization cluster.</a:t>
             </a:r>
           </a:p>
         </p:txBody>

</xml_diff>